<commit_message>
Deck v2 (preview, awaiting approval): dark navigator design, AI compass and people art
Co-Authored-By: Claude Opus 5.5 <noreply@anthropic.com>
Claude-Session: https://claude.ai/code/session_01SBiEYQB9HJW6a4Ajv4Spwg
</commit_message>
<xml_diff>
--- a/docs/presentation/Compass-Hackathon.pptx
+++ b/docs/presentation/Compass-Hackathon.pptx
@@ -123,45 +123,45 @@
   <p:extLst>
     <p:ext uri="{521415D9-36F7-43E2-AB2F-B90AF26B5E84}">
       <p14:sectionLst xmlns:p14="http://schemas.microsoft.com/office/powerpoint/2010/main">
-        <p14:section name="Opening" id="{c0c181c0-785f-cf61-d57e-6c96a04920ae}">
+        <p14:section name="Opening" id="{26f4e1cb-ef15-a23e-8bcc-860e37d77b21}">
           <p14:sldIdLst>
             <p14:sldId id="256"/>
           </p14:sldIdLst>
         </p14:section>
-        <p14:section name="Problem and solution" id="{15725e7a-b148-d90a-35ba-935a28d067ad}">
+        <p14:section name="Problem and solution" id="{61868f91-5739-a4f2-ff10-e4d1577ec654}">
           <p14:sldIdLst>
             <p14:sldId id="257"/>
             <p14:sldId id="258"/>
             <p14:sldId id="259"/>
           </p14:sldIdLst>
         </p14:section>
-        <p14:section name="How it works" id="{8e153d65-e53f-a180-cbc1-437f573ad247}">
+        <p14:section name="How it works" id="{69dbd085-b52a-a617-c83a-80a0075f39d7}">
           <p14:sldIdLst>
             <p14:sldId id="260"/>
             <p14:sldId id="261"/>
           </p14:sldIdLst>
         </p14:section>
-        <p14:section name="Demos" id="{0dd7505e-4657-637c-9e18-29fd39f7e909}">
+        <p14:section name="Demos" id="{aff05071-e84e-aa3e-a03f-574a0a605762}">
           <p14:sldIdLst>
             <p14:sldId id="262"/>
             <p14:sldId id="263"/>
             <p14:sldId id="264"/>
           </p14:sldIdLst>
         </p14:section>
-        <p14:section name="Evidence" id="{d4011dd7-9497-b531-8191-35c0a5571a1f}">
+        <p14:section name="Evidence" id="{6be4a5c9-492c-4025-fc8d-0cdff783e372}">
           <p14:sldIdLst>
             <p14:sldId id="265"/>
             <p14:sldId id="266"/>
             <p14:sldId id="269"/>
           </p14:sldIdLst>
         </p14:section>
-        <p14:section name="Trust" id="{ef16c735-ab2b-03b6-ffdf-6b55c7bc4631}">
+        <p14:section name="Trust" id="{458a04cd-67c6-f6e5-84b7-0679bb47cfaf}">
           <p14:sldIdLst>
             <p14:sldId id="267"/>
             <p14:sldId id="268"/>
           </p14:sldIdLst>
         </p14:section>
-        <p14:section name="Close" id="{c6c8640a-617f-01cc-5cbc-2f7d900bf450}">
+        <p14:section name="Close" id="{8293cb55-422a-7041-0275-e1abe60fadee}">
           <p14:sldIdLst>
             <p14:sldId id="270"/>
             <p14:sldId id="271"/>
@@ -191,7 +191,7 @@
             <a:pPr>
               <a:defRPr sz="1200" b="0" i="0" u="none" strike="noStrike">
                 <a:solidFill>
-                  <a:srgbClr val="102A35"/>
+                  <a:srgbClr val="F2F5F8"/>
                 </a:solidFill>
                 <a:latin typeface="+mn-lt"/>
               </a:defRPr>
@@ -199,7 +199,7 @@
             <a:r>
               <a:rPr sz="1200" b="0" i="0" u="none" strike="noStrike">
                 <a:solidFill>
-                  <a:srgbClr val="102A35"/>
+                  <a:srgbClr val="F2F5F8"/>
                 </a:solidFill>
                 <a:latin typeface="+mn-lt"/>
               </a:rPr>
@@ -234,7 +234,7 @@
           </c:tx>
           <c:spPr>
             <a:solidFill>
-              <a:srgbClr val="1D6E6B"/>
+              <a:srgbClr val="2EC4B6"/>
             </a:solidFill>
             <a:effectLst/>
           </c:spPr>
@@ -248,7 +248,7 @@
                 <a:pPr>
                   <a:defRPr b="0" i="0" strike="noStrike" sz="1100" u="none">
                     <a:solidFill>
-                      <a:srgbClr val="102A35"/>
+                      <a:srgbClr val="F2F5F8"/>
                     </a:solidFill>
                     <a:latin typeface="+mn-lt"/>
                   </a:defRPr>
@@ -269,7 +269,7 @@
             <c:bubble3D val="0"/>
             <c:spPr>
               <a:solidFill>
-                <a:srgbClr val="1D6E6B"/>
+                <a:srgbClr val="2EC4B6"/>
               </a:solidFill>
               <a:effectLst/>
             </c:spPr>
@@ -280,7 +280,7 @@
             <c:bubble3D val="0"/>
             <c:spPr>
               <a:solidFill>
-                <a:srgbClr val="5E7279"/>
+                <a:srgbClr val="8FA3B3"/>
               </a:solidFill>
               <a:effectLst/>
             </c:spPr>
@@ -326,7 +326,7 @@
               <a:pPr>
                 <a:defRPr b="0" i="0" strike="noStrike" sz="1100" u="none">
                   <a:solidFill>
-                    <a:srgbClr val="102A35"/>
+                    <a:srgbClr val="F2F5F8"/>
                   </a:solidFill>
                   <a:latin typeface="+mn-lt"/>
                 </a:defRPr>
@@ -374,7 +374,7 @@
             <a:pPr>
               <a:defRPr sz="1100" b="0" i="0" u="none" strike="noStrike">
                 <a:solidFill>
-                  <a:srgbClr val="5E7279"/>
+                  <a:srgbClr val="8FA3B3"/>
                 </a:solidFill>
                 <a:latin typeface="+mn-lt"/>
               </a:defRPr>
@@ -401,7 +401,7 @@
           <c:spPr>
             <a:ln w="6350" cap="flat">
               <a:solidFill>
-                <a:srgbClr val="DCE6E4"/>
+                <a:srgbClr val="2F4A63"/>
               </a:solidFill>
               <a:prstDash val="solid"/>
               <a:round/>
@@ -428,7 +428,7 @@
             <a:pPr>
               <a:defRPr sz="900" b="0" i="0" u="none" strike="noStrike">
                 <a:solidFill>
-                  <a:srgbClr val="5E7279"/>
+                  <a:srgbClr val="8FA3B3"/>
                 </a:solidFill>
                 <a:latin typeface="+mn-lt"/>
               </a:defRPr>
@@ -2345,7 +2345,7 @@
     <p:bg>
       <p:bgPr>
         <a:solidFill>
-          <a:srgbClr val="102A35"/>
+          <a:srgbClr val="071421"/>
         </a:solidFill>
       </p:bgPr>
     </p:bg>
@@ -2389,7 +2389,7 @@
               <a:buNone/>
               <a:defRPr lang="en-US" sz="4800" b="1" dirty="0">
                 <a:solidFill>
-                  <a:schemeClr val="bg1"/>
+                  <a:schemeClr val="tx1"/>
                 </a:solidFill>
                 <a:latin typeface="Cambria" pitchFamily="34" charset="0"/>
                 <a:ea typeface="Cambria" pitchFamily="34" charset="-122"/>
@@ -2431,7 +2431,7 @@
               <a:buNone/>
               <a:defRPr lang="en-US" sz="1600" dirty="0">
                 <a:solidFill>
-                  <a:schemeClr val="accent6"/>
+                  <a:schemeClr val="accent5"/>
                 </a:solidFill>
               </a:defRPr>
             </a:lvl1pPr>
@@ -2458,7 +2458,7 @@
     <p:bg>
       <p:bgPr>
         <a:solidFill>
-          <a:srgbClr val="102A35"/>
+          <a:srgbClr val="071421"/>
         </a:solidFill>
       </p:bgPr>
     </p:bg>
@@ -2502,7 +2502,7 @@
               <a:buNone/>
               <a:defRPr lang="en-US" sz="3600" b="1" dirty="0">
                 <a:solidFill>
-                  <a:schemeClr val="bg1"/>
+                  <a:schemeClr val="tx1"/>
                 </a:solidFill>
                 <a:latin typeface="Cambria" pitchFamily="34" charset="0"/>
                 <a:ea typeface="Cambria" pitchFamily="34" charset="-122"/>
@@ -2544,7 +2544,7 @@
               <a:buNone/>
               <a:defRPr lang="en-US" sz="1500" dirty="0">
                 <a:solidFill>
-                  <a:schemeClr val="accent6"/>
+                  <a:schemeClr val="accent5"/>
                 </a:solidFill>
               </a:defRPr>
             </a:lvl1pPr>
@@ -2571,7 +2571,7 @@
     <p:bg>
       <p:bgPr>
         <a:solidFill>
-          <a:srgbClr val="FFFFFF"/>
+          <a:srgbClr val="0B1B2B"/>
         </a:solidFill>
       </p:bgPr>
     </p:bg>
@@ -3091,7 +3091,7 @@
             <a:r>
               <a:rPr lang="en-US" sz="4800" b="1" dirty="0">
                 <a:solidFill>
-                  <a:schemeClr val="bg1"/>
+                  <a:schemeClr val="tx1"/>
                 </a:solidFill>
                 <a:latin typeface="Cambria" pitchFamily="34" charset="0"/>
                 <a:ea typeface="Cambria" pitchFamily="34" charset="-122"/>
@@ -3132,7 +3132,7 @@
             <a:r>
               <a:rPr lang="en-US" sz="2200" b="1" dirty="0">
                 <a:solidFill>
-                  <a:schemeClr val="bg1"/>
+                  <a:schemeClr val="accent2"/>
                 </a:solidFill>
               </a:rPr>
               <a:t>Right tool. Sharp prompt. Proven result.</a:t>
@@ -3146,7 +3146,7 @@
             <a:r>
               <a:rPr lang="en-US" sz="800" dirty="0">
                 <a:solidFill>
-                  <a:schemeClr val="accent6"/>
+                  <a:schemeClr val="accent5"/>
                 </a:solidFill>
               </a:rPr>
               <a:t> </a:t>
@@ -3160,7 +3160,7 @@
             <a:r>
               <a:rPr lang="en-US" sz="1600" dirty="0">
                 <a:solidFill>
-                  <a:schemeClr val="accent6"/>
+                  <a:schemeClr val="accent5"/>
                 </a:solidFill>
               </a:rPr>
               <a:t>Private GenAI coaching that guides every engineer the right way</a:t>
@@ -3174,7 +3174,7 @@
             <a:r>
               <a:rPr lang="en-US" sz="1200" dirty="0">
                 <a:solidFill>
-                  <a:schemeClr val="accent6"/>
+                  <a:schemeClr val="accent5"/>
                 </a:solidFill>
               </a:rPr>
               <a:t>AI Engineering Enablement Coach  |  Hackathon submission</a:t>
@@ -3188,7 +3188,7 @@
             <a:r>
               <a:rPr lang="en-US" sz="1200" dirty="0">
                 <a:solidFill>
-                  <a:schemeClr val="accent6"/>
+                  <a:schemeClr val="accent5"/>
                 </a:solidFill>
               </a:rPr>
               <a:t>Synthetic data only. Runs on a laptop. No API keys.</a:t>
@@ -3213,8 +3213,8 @@
         </p:blipFill>
         <p:spPr>
           <a:xfrm>
-            <a:off x="5440680" y="868680"/>
-            <a:ext cx="3383280" cy="3383280"/>
+            <a:off x="5303520" y="685800"/>
+            <a:ext cx="3703320" cy="3703320"/>
           </a:xfrm>
           <a:prstGeom prst="rect">
             <a:avLst/>
@@ -4133,8 +4133,8 @@
           <a:ln/>
           <a:effectLst>
             <a:outerShdw sx="100000" sy="100000" kx="0" ky="0" algn="bl" rotWithShape="0" blurRad="76200" dist="25400" dir="5400000">
-              <a:srgbClr val="1A3640">
-                <a:alpha val="14000"/>
+              <a:srgbClr val="000000">
+                <a:alpha val="35000"/>
               </a:srgbClr>
             </a:outerShdw>
           </a:effectLst>
@@ -4209,14 +4209,14 @@
           </a:solidFill>
           <a:ln w="12700">
             <a:solidFill>
-              <a:srgbClr val="A9CFC9"/>
+              <a:srgbClr val="2F4A63"/>
             </a:solidFill>
             <a:prstDash val="solid"/>
           </a:ln>
           <a:effectLst>
             <a:outerShdw sx="100000" sy="100000" kx="0" ky="0" algn="bl" rotWithShape="0" blurRad="76200" dist="25400" dir="5400000">
-              <a:srgbClr val="1A3640">
-                <a:alpha val="14000"/>
+              <a:srgbClr val="000000">
+                <a:alpha val="35000"/>
               </a:srgbClr>
             </a:outerShdw>
           </a:effectLst>
@@ -4379,7 +4379,7 @@
       </p:sp>
       <p:pic>
         <p:nvPicPr>
-          <p:cNvPr id="4" name="Image 0" descr="/tmp/claude-0/-home-claude-compass-ai-coach/3958fdaf-6357-5283-9722-e914f4fad239/scratchpad/deck/img/db-w.png">    </p:cNvPr>
+          <p:cNvPr id="4" name="Image 0" descr="/tmp/claude-0/-home-claude-compass-ai-coach/3958fdaf-6357-5283-9722-e914f4fad239/scratchpad/deck/img/db-d.png">    </p:cNvPr>
           <p:cNvPicPr>
             <a:picLocks noChangeAspect="1"/>
           </p:cNvPicPr>
@@ -4495,7 +4495,7 @@
       </p:sp>
       <p:pic>
         <p:nvPicPr>
-          <p:cNvPr id="8" name="Image 1" descr="/tmp/claude-0/-home-claude-compass-ai-coach/3958fdaf-6357-5283-9722-e914f4fad239/scratchpad/deck/img/users-w.png">    </p:cNvPr>
+          <p:cNvPr id="8" name="Image 1" descr="/tmp/claude-0/-home-claude-compass-ai-coach/3958fdaf-6357-5283-9722-e914f4fad239/scratchpad/deck/img/users-d.png">    </p:cNvPr>
           <p:cNvPicPr>
             <a:picLocks noChangeAspect="1"/>
           </p:cNvPicPr>
@@ -4611,7 +4611,7 @@
       </p:sp>
       <p:pic>
         <p:nvPicPr>
-          <p:cNvPr id="12" name="Image 2" descr="/tmp/claude-0/-home-claude-compass-ai-coach/3958fdaf-6357-5283-9722-e914f4fad239/scratchpad/deck/img/ban-w.png">    </p:cNvPr>
+          <p:cNvPr id="12" name="Image 2" descr="/tmp/claude-0/-home-claude-compass-ai-coach/3958fdaf-6357-5283-9722-e914f4fad239/scratchpad/deck/img/ban-d.png">    </p:cNvPr>
           <p:cNvPicPr>
             <a:picLocks noChangeAspect="1"/>
           </p:cNvPicPr>
@@ -4727,7 +4727,7 @@
       </p:sp>
       <p:pic>
         <p:nvPicPr>
-          <p:cNvPr id="16" name="Image 3" descr="/tmp/claude-0/-home-claude-compass-ai-coach/3958fdaf-6357-5283-9722-e914f4fad239/scratchpad/deck/img/eye-w.png">    </p:cNvPr>
+          <p:cNvPr id="16" name="Image 3" descr="/tmp/claude-0/-home-claude-compass-ai-coach/3958fdaf-6357-5283-9722-e914f4fad239/scratchpad/deck/img/eye-d.png">    </p:cNvPr>
           <p:cNvPicPr>
             <a:picLocks noChangeAspect="1"/>
           </p:cNvPicPr>
@@ -4843,7 +4843,7 @@
       </p:sp>
       <p:pic>
         <p:nvPicPr>
-          <p:cNvPr id="20" name="Image 4" descr="/tmp/claude-0/-home-claude-compass-ai-coach/3958fdaf-6357-5283-9722-e914f4fad239/scratchpad/deck/img/filter-w.png">    </p:cNvPr>
+          <p:cNvPr id="20" name="Image 4" descr="/tmp/claude-0/-home-claude-compass-ai-coach/3958fdaf-6357-5283-9722-e914f4fad239/scratchpad/deck/img/filter-d.png">    </p:cNvPr>
           <p:cNvPicPr>
             <a:picLocks noChangeAspect="1"/>
           </p:cNvPicPr>
@@ -4956,14 +4956,14 @@
           </a:solidFill>
           <a:ln w="12700">
             <a:solidFill>
-              <a:srgbClr val="A9CFC9"/>
+              <a:srgbClr val="2F4A63"/>
             </a:solidFill>
             <a:prstDash val="solid"/>
           </a:ln>
           <a:effectLst>
             <a:outerShdw sx="100000" sy="100000" kx="0" ky="0" algn="bl" rotWithShape="0" blurRad="76200" dist="25400" dir="5400000">
-              <a:srgbClr val="1A3640">
-                <a:alpha val="14000"/>
+              <a:srgbClr val="000000">
+                <a:alpha val="35000"/>
               </a:srgbClr>
             </a:outerShdw>
           </a:effectLst>
@@ -5162,8 +5162,8 @@
           <a:ln/>
           <a:effectLst>
             <a:outerShdw sx="100000" sy="100000" kx="0" ky="0" algn="bl" rotWithShape="0" blurRad="76200" dist="25400" dir="5400000">
-              <a:srgbClr val="1A3640">
-                <a:alpha val="14000"/>
+              <a:srgbClr val="000000">
+                <a:alpha val="35000"/>
               </a:srgbClr>
             </a:outerShdw>
           </a:effectLst>
@@ -5191,7 +5191,7 @@
       </p:sp>
       <p:pic>
         <p:nvPicPr>
-          <p:cNvPr id="5" name="Image 0" descr="/tmp/claude-0/-home-claude-compass-ai-coach/3958fdaf-6357-5283-9722-e914f4fad239/scratchpad/deck/img/terminal-w.png">    </p:cNvPr>
+          <p:cNvPr id="5" name="Image 0" descr="/tmp/claude-0/-home-claude-compass-ai-coach/3958fdaf-6357-5283-9722-e914f4fad239/scratchpad/deck/img/terminal-d.png">    </p:cNvPr>
           <p:cNvPicPr>
             <a:picLocks noChangeAspect="1"/>
           </p:cNvPicPr>
@@ -5307,8 +5307,8 @@
           <a:ln/>
           <a:effectLst>
             <a:outerShdw sx="100000" sy="100000" kx="0" ky="0" algn="bl" rotWithShape="0" blurRad="76200" dist="25400" dir="5400000">
-              <a:srgbClr val="1A3640">
-                <a:alpha val="14000"/>
+              <a:srgbClr val="000000">
+                <a:alpha val="35000"/>
               </a:srgbClr>
             </a:outerShdw>
           </a:effectLst>
@@ -5336,7 +5336,7 @@
       </p:sp>
       <p:pic>
         <p:nvPicPr>
-          <p:cNvPr id="10" name="Image 1" descr="/tmp/claude-0/-home-claude-compass-ai-coach/3958fdaf-6357-5283-9722-e914f4fad239/scratchpad/deck/img/fingerprint-w.png">    </p:cNvPr>
+          <p:cNvPr id="10" name="Image 1" descr="/tmp/claude-0/-home-claude-compass-ai-coach/3958fdaf-6357-5283-9722-e914f4fad239/scratchpad/deck/img/fingerprint-d.png">    </p:cNvPr>
           <p:cNvPicPr>
             <a:picLocks noChangeAspect="1"/>
           </p:cNvPicPr>
@@ -5452,8 +5452,8 @@
           <a:ln/>
           <a:effectLst>
             <a:outerShdw sx="100000" sy="100000" kx="0" ky="0" algn="bl" rotWithShape="0" blurRad="76200" dist="25400" dir="5400000">
-              <a:srgbClr val="1A3640">
-                <a:alpha val="14000"/>
+              <a:srgbClr val="000000">
+                <a:alpha val="35000"/>
               </a:srgbClr>
             </a:outerShdw>
           </a:effectLst>
@@ -5481,7 +5481,7 @@
       </p:sp>
       <p:pic>
         <p:nvPicPr>
-          <p:cNvPr id="15" name="Image 2" descr="/tmp/claude-0/-home-claude-compass-ai-coach/3958fdaf-6357-5283-9722-e914f4fad239/scratchpad/deck/img/folder-w.png">    </p:cNvPr>
+          <p:cNvPr id="15" name="Image 2" descr="/tmp/claude-0/-home-claude-compass-ai-coach/3958fdaf-6357-5283-9722-e914f4fad239/scratchpad/deck/img/folder-d.png">    </p:cNvPr>
           <p:cNvPicPr>
             <a:picLocks noChangeAspect="1"/>
           </p:cNvPicPr>
@@ -5597,8 +5597,8 @@
           <a:ln/>
           <a:effectLst>
             <a:outerShdw sx="100000" sy="100000" kx="0" ky="0" algn="bl" rotWithShape="0" blurRad="76200" dist="25400" dir="5400000">
-              <a:srgbClr val="1A3640">
-                <a:alpha val="14000"/>
+              <a:srgbClr val="000000">
+                <a:alpha val="35000"/>
               </a:srgbClr>
             </a:outerShdw>
           </a:effectLst>
@@ -5626,7 +5626,7 @@
       </p:sp>
       <p:pic>
         <p:nvPicPr>
-          <p:cNvPr id="20" name="Image 3" descr="/tmp/claude-0/-home-claude-compass-ai-coach/3958fdaf-6357-5283-9722-e914f4fad239/scratchpad/deck/img/shield-w.png">    </p:cNvPr>
+          <p:cNvPr id="20" name="Image 3" descr="/tmp/claude-0/-home-claude-compass-ai-coach/3958fdaf-6357-5283-9722-e914f4fad239/scratchpad/deck/img/shield-d.png">    </p:cNvPr>
           <p:cNvPicPr>
             <a:picLocks noChangeAspect="1"/>
           </p:cNvPicPr>
@@ -5742,8 +5742,8 @@
           <a:ln/>
           <a:effectLst>
             <a:outerShdw sx="100000" sy="100000" kx="0" ky="0" algn="bl" rotWithShape="0" blurRad="76200" dist="25400" dir="5400000">
-              <a:srgbClr val="1A3640">
-                <a:alpha val="14000"/>
+              <a:srgbClr val="000000">
+                <a:alpha val="35000"/>
               </a:srgbClr>
             </a:outerShdw>
           </a:effectLst>
@@ -5771,7 +5771,7 @@
       </p:sp>
       <p:pic>
         <p:nvPicPr>
-          <p:cNvPr id="25" name="Image 4" descr="/tmp/claude-0/-home-claude-compass-ai-coach/3958fdaf-6357-5283-9722-e914f4fad239/scratchpad/deck/img/network-w.png">    </p:cNvPr>
+          <p:cNvPr id="25" name="Image 4" descr="/tmp/claude-0/-home-claude-compass-ai-coach/3958fdaf-6357-5283-9722-e914f4fad239/scratchpad/deck/img/network-d.png">    </p:cNvPr>
           <p:cNvPicPr>
             <a:picLocks noChangeAspect="1"/>
           </p:cNvPicPr>
@@ -5887,8 +5887,8 @@
           <a:ln/>
           <a:effectLst>
             <a:outerShdw sx="100000" sy="100000" kx="0" ky="0" algn="bl" rotWithShape="0" blurRad="76200" dist="25400" dir="5400000">
-              <a:srgbClr val="1A3640">
-                <a:alpha val="14000"/>
+              <a:srgbClr val="000000">
+                <a:alpha val="35000"/>
               </a:srgbClr>
             </a:outerShdw>
           </a:effectLst>
@@ -5916,7 +5916,7 @@
       </p:sp>
       <p:pic>
         <p:nvPicPr>
-          <p:cNvPr id="30" name="Image 5" descr="/tmp/claude-0/-home-claude-compass-ai-coach/3958fdaf-6357-5283-9722-e914f4fad239/scratchpad/deck/img/key-w.png">    </p:cNvPr>
+          <p:cNvPr id="30" name="Image 5" descr="/tmp/claude-0/-home-claude-compass-ai-coach/3958fdaf-6357-5283-9722-e914f4fad239/scratchpad/deck/img/key-d.png">    </p:cNvPr>
           <p:cNvPicPr>
             <a:picLocks noChangeAspect="1"/>
           </p:cNvPicPr>
@@ -6143,8 +6143,8 @@
           <a:ln/>
           <a:effectLst>
             <a:outerShdw sx="100000" sy="100000" kx="0" ky="0" algn="bl" rotWithShape="0" blurRad="76200" dist="25400" dir="5400000">
-              <a:srgbClr val="1A3640">
-                <a:alpha val="14000"/>
+              <a:srgbClr val="000000">
+                <a:alpha val="35000"/>
               </a:srgbClr>
             </a:outerShdw>
           </a:effectLst>
@@ -6247,8 +6247,8 @@
           <a:ln/>
           <a:effectLst>
             <a:outerShdw sx="100000" sy="100000" kx="0" ky="0" algn="bl" rotWithShape="0" blurRad="76200" dist="25400" dir="5400000">
-              <a:srgbClr val="1A3640">
-                <a:alpha val="14000"/>
+              <a:srgbClr val="000000">
+                <a:alpha val="35000"/>
               </a:srgbClr>
             </a:outerShdw>
           </a:effectLst>
@@ -6351,8 +6351,8 @@
           <a:ln/>
           <a:effectLst>
             <a:outerShdw sx="100000" sy="100000" kx="0" ky="0" algn="bl" rotWithShape="0" blurRad="76200" dist="25400" dir="5400000">
-              <a:srgbClr val="1A3640">
-                <a:alpha val="14000"/>
+              <a:srgbClr val="000000">
+                <a:alpha val="35000"/>
               </a:srgbClr>
             </a:outerShdw>
           </a:effectLst>
@@ -6455,8 +6455,8 @@
           <a:ln/>
           <a:effectLst>
             <a:outerShdw sx="100000" sy="100000" kx="0" ky="0" algn="bl" rotWithShape="0" blurRad="76200" dist="25400" dir="5400000">
-              <a:srgbClr val="1A3640">
-                <a:alpha val="14000"/>
+              <a:srgbClr val="000000">
+                <a:alpha val="35000"/>
               </a:srgbClr>
             </a:outerShdw>
           </a:effectLst>
@@ -6558,7 +6558,7 @@
           </a:solidFill>
           <a:ln w="12700">
             <a:solidFill>
-              <a:srgbClr val="A9CFC9"/>
+              <a:srgbClr val="2F4A63"/>
             </a:solidFill>
             <a:prstDash val="solid"/>
           </a:ln>
@@ -6586,7 +6586,7 @@
       </p:sp>
       <p:pic>
         <p:nvPicPr>
-          <p:cNvPr id="17" name="Image 0" descr="/tmp/claude-0/-home-claude-compass-ai-coach/3958fdaf-6357-5283-9722-e914f4fad239/scratchpad/deck/img/check-w.png">    </p:cNvPr>
+          <p:cNvPr id="17" name="Image 0" descr="/tmp/claude-0/-home-claude-compass-ai-coach/3958fdaf-6357-5283-9722-e914f4fad239/scratchpad/deck/img/check-d.png">    </p:cNvPr>
           <p:cNvPicPr>
             <a:picLocks noChangeAspect="1"/>
           </p:cNvPicPr>
@@ -6845,7 +6845,7 @@
                   <a:tcPr marL="73152" marR="73152" marT="73152" marB="73152" anchor="ctr">
                     <a:lnL w="6350" cap="flat" cmpd="sng" algn="ctr">
                       <a:solidFill>
-                        <a:srgbClr val="A9CFC9"/>
+                        <a:srgbClr val="2F4A63"/>
                       </a:solidFill>
                       <a:prstDash val="solid"/>
                       <a:round/>
@@ -6854,7 +6854,7 @@
                     </a:lnL>
                     <a:lnR w="6350" cap="flat" cmpd="sng" algn="ctr">
                       <a:solidFill>
-                        <a:srgbClr val="A9CFC9"/>
+                        <a:srgbClr val="2F4A63"/>
                       </a:solidFill>
                       <a:prstDash val="solid"/>
                       <a:round/>
@@ -6863,7 +6863,7 @@
                     </a:lnR>
                     <a:lnT w="6350" cap="flat" cmpd="sng" algn="ctr">
                       <a:solidFill>
-                        <a:srgbClr val="A9CFC9"/>
+                        <a:srgbClr val="2F4A63"/>
                       </a:solidFill>
                       <a:prstDash val="solid"/>
                       <a:round/>
@@ -6872,7 +6872,7 @@
                     </a:lnT>
                     <a:lnB w="6350" cap="flat" cmpd="sng" algn="ctr">
                       <a:solidFill>
-                        <a:srgbClr val="A9CFC9"/>
+                        <a:srgbClr val="2F4A63"/>
                       </a:solidFill>
                       <a:prstDash val="solid"/>
                       <a:round/>
@@ -6906,7 +6906,7 @@
                   <a:tcPr marL="73152" marR="73152" marT="73152" marB="73152" anchor="ctr">
                     <a:lnL w="6350" cap="flat" cmpd="sng" algn="ctr">
                       <a:solidFill>
-                        <a:srgbClr val="A9CFC9"/>
+                        <a:srgbClr val="2F4A63"/>
                       </a:solidFill>
                       <a:prstDash val="solid"/>
                       <a:round/>
@@ -6915,7 +6915,7 @@
                     </a:lnL>
                     <a:lnR w="6350" cap="flat" cmpd="sng" algn="ctr">
                       <a:solidFill>
-                        <a:srgbClr val="A9CFC9"/>
+                        <a:srgbClr val="2F4A63"/>
                       </a:solidFill>
                       <a:prstDash val="solid"/>
                       <a:round/>
@@ -6924,7 +6924,7 @@
                     </a:lnR>
                     <a:lnT w="6350" cap="flat" cmpd="sng" algn="ctr">
                       <a:solidFill>
-                        <a:srgbClr val="A9CFC9"/>
+                        <a:srgbClr val="2F4A63"/>
                       </a:solidFill>
                       <a:prstDash val="solid"/>
                       <a:round/>
@@ -6933,7 +6933,7 @@
                     </a:lnT>
                     <a:lnB w="6350" cap="flat" cmpd="sng" algn="ctr">
                       <a:solidFill>
-                        <a:srgbClr val="A9CFC9"/>
+                        <a:srgbClr val="2F4A63"/>
                       </a:solidFill>
                       <a:prstDash val="solid"/>
                       <a:round/>
@@ -6967,7 +6967,7 @@
                   <a:tcPr marL="73152" marR="73152" marT="73152" marB="73152" anchor="ctr">
                     <a:lnL w="6350" cap="flat" cmpd="sng" algn="ctr">
                       <a:solidFill>
-                        <a:srgbClr val="A9CFC9"/>
+                        <a:srgbClr val="2F4A63"/>
                       </a:solidFill>
                       <a:prstDash val="solid"/>
                       <a:round/>
@@ -6976,7 +6976,7 @@
                     </a:lnL>
                     <a:lnR w="6350" cap="flat" cmpd="sng" algn="ctr">
                       <a:solidFill>
-                        <a:srgbClr val="A9CFC9"/>
+                        <a:srgbClr val="2F4A63"/>
                       </a:solidFill>
                       <a:prstDash val="solid"/>
                       <a:round/>
@@ -6985,7 +6985,7 @@
                     </a:lnR>
                     <a:lnT w="6350" cap="flat" cmpd="sng" algn="ctr">
                       <a:solidFill>
-                        <a:srgbClr val="A9CFC9"/>
+                        <a:srgbClr val="2F4A63"/>
                       </a:solidFill>
                       <a:prstDash val="solid"/>
                       <a:round/>
@@ -6994,7 +6994,7 @@
                     </a:lnT>
                     <a:lnB w="6350" cap="flat" cmpd="sng" algn="ctr">
                       <a:solidFill>
-                        <a:srgbClr val="A9CFC9"/>
+                        <a:srgbClr val="2F4A63"/>
                       </a:solidFill>
                       <a:prstDash val="solid"/>
                       <a:round/>
@@ -7030,7 +7030,7 @@
                   <a:tcPr marL="73152" marR="73152" marT="73152" marB="73152" anchor="ctr">
                     <a:lnL w="6350" cap="flat" cmpd="sng" algn="ctr">
                       <a:solidFill>
-                        <a:srgbClr val="A9CFC9"/>
+                        <a:srgbClr val="2F4A63"/>
                       </a:solidFill>
                       <a:prstDash val="solid"/>
                       <a:round/>
@@ -7039,7 +7039,7 @@
                     </a:lnL>
                     <a:lnR w="6350" cap="flat" cmpd="sng" algn="ctr">
                       <a:solidFill>
-                        <a:srgbClr val="A9CFC9"/>
+                        <a:srgbClr val="2F4A63"/>
                       </a:solidFill>
                       <a:prstDash val="solid"/>
                       <a:round/>
@@ -7048,7 +7048,7 @@
                     </a:lnR>
                     <a:lnT w="6350" cap="flat" cmpd="sng" algn="ctr">
                       <a:solidFill>
-                        <a:srgbClr val="A9CFC9"/>
+                        <a:srgbClr val="2F4A63"/>
                       </a:solidFill>
                       <a:prstDash val="solid"/>
                       <a:round/>
@@ -7057,7 +7057,7 @@
                     </a:lnT>
                     <a:lnB w="6350" cap="flat" cmpd="sng" algn="ctr">
                       <a:solidFill>
-                        <a:srgbClr val="A9CFC9"/>
+                        <a:srgbClr val="2F4A63"/>
                       </a:solidFill>
                       <a:prstDash val="solid"/>
                       <a:round/>
@@ -7091,7 +7091,7 @@
                   <a:tcPr marL="73152" marR="73152" marT="73152" marB="73152" anchor="ctr">
                     <a:lnL w="6350" cap="flat" cmpd="sng" algn="ctr">
                       <a:solidFill>
-                        <a:srgbClr val="A9CFC9"/>
+                        <a:srgbClr val="2F4A63"/>
                       </a:solidFill>
                       <a:prstDash val="solid"/>
                       <a:round/>
@@ -7100,7 +7100,7 @@
                     </a:lnL>
                     <a:lnR w="6350" cap="flat" cmpd="sng" algn="ctr">
                       <a:solidFill>
-                        <a:srgbClr val="A9CFC9"/>
+                        <a:srgbClr val="2F4A63"/>
                       </a:solidFill>
                       <a:prstDash val="solid"/>
                       <a:round/>
@@ -7109,7 +7109,7 @@
                     </a:lnR>
                     <a:lnT w="6350" cap="flat" cmpd="sng" algn="ctr">
                       <a:solidFill>
-                        <a:srgbClr val="A9CFC9"/>
+                        <a:srgbClr val="2F4A63"/>
                       </a:solidFill>
                       <a:prstDash val="solid"/>
                       <a:round/>
@@ -7118,7 +7118,7 @@
                     </a:lnT>
                     <a:lnB w="6350" cap="flat" cmpd="sng" algn="ctr">
                       <a:solidFill>
-                        <a:srgbClr val="A9CFC9"/>
+                        <a:srgbClr val="2F4A63"/>
                       </a:solidFill>
                       <a:prstDash val="solid"/>
                       <a:round/>
@@ -7152,7 +7152,7 @@
                   <a:tcPr marL="73152" marR="73152" marT="73152" marB="73152" anchor="ctr">
                     <a:lnL w="6350" cap="flat" cmpd="sng" algn="ctr">
                       <a:solidFill>
-                        <a:srgbClr val="A9CFC9"/>
+                        <a:srgbClr val="2F4A63"/>
                       </a:solidFill>
                       <a:prstDash val="solid"/>
                       <a:round/>
@@ -7161,7 +7161,7 @@
                     </a:lnL>
                     <a:lnR w="6350" cap="flat" cmpd="sng" algn="ctr">
                       <a:solidFill>
-                        <a:srgbClr val="A9CFC9"/>
+                        <a:srgbClr val="2F4A63"/>
                       </a:solidFill>
                       <a:prstDash val="solid"/>
                       <a:round/>
@@ -7170,7 +7170,7 @@
                     </a:lnR>
                     <a:lnT w="6350" cap="flat" cmpd="sng" algn="ctr">
                       <a:solidFill>
-                        <a:srgbClr val="A9CFC9"/>
+                        <a:srgbClr val="2F4A63"/>
                       </a:solidFill>
                       <a:prstDash val="solid"/>
                       <a:round/>
@@ -7179,7 +7179,7 @@
                     </a:lnT>
                     <a:lnB w="6350" cap="flat" cmpd="sng" algn="ctr">
                       <a:solidFill>
-                        <a:srgbClr val="A9CFC9"/>
+                        <a:srgbClr val="2F4A63"/>
                       </a:solidFill>
                       <a:prstDash val="solid"/>
                       <a:round/>
@@ -7215,7 +7215,7 @@
                   <a:tcPr marL="73152" marR="73152" marT="73152" marB="73152" anchor="ctr">
                     <a:lnL w="6350" cap="flat" cmpd="sng" algn="ctr">
                       <a:solidFill>
-                        <a:srgbClr val="A9CFC9"/>
+                        <a:srgbClr val="2F4A63"/>
                       </a:solidFill>
                       <a:prstDash val="solid"/>
                       <a:round/>
@@ -7224,7 +7224,7 @@
                     </a:lnL>
                     <a:lnR w="6350" cap="flat" cmpd="sng" algn="ctr">
                       <a:solidFill>
-                        <a:srgbClr val="A9CFC9"/>
+                        <a:srgbClr val="2F4A63"/>
                       </a:solidFill>
                       <a:prstDash val="solid"/>
                       <a:round/>
@@ -7233,7 +7233,7 @@
                     </a:lnR>
                     <a:lnT w="6350" cap="flat" cmpd="sng" algn="ctr">
                       <a:solidFill>
-                        <a:srgbClr val="A9CFC9"/>
+                        <a:srgbClr val="2F4A63"/>
                       </a:solidFill>
                       <a:prstDash val="solid"/>
                       <a:round/>
@@ -7242,7 +7242,7 @@
                     </a:lnT>
                     <a:lnB w="6350" cap="flat" cmpd="sng" algn="ctr">
                       <a:solidFill>
-                        <a:srgbClr val="A9CFC9"/>
+                        <a:srgbClr val="2F4A63"/>
                       </a:solidFill>
                       <a:prstDash val="solid"/>
                       <a:round/>
@@ -7276,7 +7276,7 @@
                   <a:tcPr marL="73152" marR="73152" marT="73152" marB="73152" anchor="ctr">
                     <a:lnL w="6350" cap="flat" cmpd="sng" algn="ctr">
                       <a:solidFill>
-                        <a:srgbClr val="A9CFC9"/>
+                        <a:srgbClr val="2F4A63"/>
                       </a:solidFill>
                       <a:prstDash val="solid"/>
                       <a:round/>
@@ -7285,7 +7285,7 @@
                     </a:lnL>
                     <a:lnR w="6350" cap="flat" cmpd="sng" algn="ctr">
                       <a:solidFill>
-                        <a:srgbClr val="A9CFC9"/>
+                        <a:srgbClr val="2F4A63"/>
                       </a:solidFill>
                       <a:prstDash val="solid"/>
                       <a:round/>
@@ -7294,7 +7294,7 @@
                     </a:lnR>
                     <a:lnT w="6350" cap="flat" cmpd="sng" algn="ctr">
                       <a:solidFill>
-                        <a:srgbClr val="A9CFC9"/>
+                        <a:srgbClr val="2F4A63"/>
                       </a:solidFill>
                       <a:prstDash val="solid"/>
                       <a:round/>
@@ -7303,7 +7303,7 @@
                     </a:lnT>
                     <a:lnB w="6350" cap="flat" cmpd="sng" algn="ctr">
                       <a:solidFill>
-                        <a:srgbClr val="A9CFC9"/>
+                        <a:srgbClr val="2F4A63"/>
                       </a:solidFill>
                       <a:prstDash val="solid"/>
                       <a:round/>
@@ -7337,7 +7337,7 @@
                   <a:tcPr marL="73152" marR="73152" marT="73152" marB="73152" anchor="ctr">
                     <a:lnL w="6350" cap="flat" cmpd="sng" algn="ctr">
                       <a:solidFill>
-                        <a:srgbClr val="A9CFC9"/>
+                        <a:srgbClr val="2F4A63"/>
                       </a:solidFill>
                       <a:prstDash val="solid"/>
                       <a:round/>
@@ -7346,7 +7346,7 @@
                     </a:lnL>
                     <a:lnR w="6350" cap="flat" cmpd="sng" algn="ctr">
                       <a:solidFill>
-                        <a:srgbClr val="A9CFC9"/>
+                        <a:srgbClr val="2F4A63"/>
                       </a:solidFill>
                       <a:prstDash val="solid"/>
                       <a:round/>
@@ -7355,7 +7355,7 @@
                     </a:lnR>
                     <a:lnT w="6350" cap="flat" cmpd="sng" algn="ctr">
                       <a:solidFill>
-                        <a:srgbClr val="A9CFC9"/>
+                        <a:srgbClr val="2F4A63"/>
                       </a:solidFill>
                       <a:prstDash val="solid"/>
                       <a:round/>
@@ -7364,7 +7364,7 @@
                     </a:lnT>
                     <a:lnB w="6350" cap="flat" cmpd="sng" algn="ctr">
                       <a:solidFill>
-                        <a:srgbClr val="A9CFC9"/>
+                        <a:srgbClr val="2F4A63"/>
                       </a:solidFill>
                       <a:prstDash val="solid"/>
                       <a:round/>
@@ -7400,7 +7400,7 @@
                   <a:tcPr marL="73152" marR="73152" marT="73152" marB="73152" anchor="ctr">
                     <a:lnL w="6350" cap="flat" cmpd="sng" algn="ctr">
                       <a:solidFill>
-                        <a:srgbClr val="A9CFC9"/>
+                        <a:srgbClr val="2F4A63"/>
                       </a:solidFill>
                       <a:prstDash val="solid"/>
                       <a:round/>
@@ -7409,7 +7409,7 @@
                     </a:lnL>
                     <a:lnR w="6350" cap="flat" cmpd="sng" algn="ctr">
                       <a:solidFill>
-                        <a:srgbClr val="A9CFC9"/>
+                        <a:srgbClr val="2F4A63"/>
                       </a:solidFill>
                       <a:prstDash val="solid"/>
                       <a:round/>
@@ -7418,7 +7418,7 @@
                     </a:lnR>
                     <a:lnT w="6350" cap="flat" cmpd="sng" algn="ctr">
                       <a:solidFill>
-                        <a:srgbClr val="A9CFC9"/>
+                        <a:srgbClr val="2F4A63"/>
                       </a:solidFill>
                       <a:prstDash val="solid"/>
                       <a:round/>
@@ -7427,7 +7427,7 @@
                     </a:lnT>
                     <a:lnB w="6350" cap="flat" cmpd="sng" algn="ctr">
                       <a:solidFill>
-                        <a:srgbClr val="A9CFC9"/>
+                        <a:srgbClr val="2F4A63"/>
                       </a:solidFill>
                       <a:prstDash val="solid"/>
                       <a:round/>
@@ -7461,7 +7461,7 @@
                   <a:tcPr marL="73152" marR="73152" marT="73152" marB="73152" anchor="ctr">
                     <a:lnL w="6350" cap="flat" cmpd="sng" algn="ctr">
                       <a:solidFill>
-                        <a:srgbClr val="A9CFC9"/>
+                        <a:srgbClr val="2F4A63"/>
                       </a:solidFill>
                       <a:prstDash val="solid"/>
                       <a:round/>
@@ -7470,7 +7470,7 @@
                     </a:lnL>
                     <a:lnR w="6350" cap="flat" cmpd="sng" algn="ctr">
                       <a:solidFill>
-                        <a:srgbClr val="A9CFC9"/>
+                        <a:srgbClr val="2F4A63"/>
                       </a:solidFill>
                       <a:prstDash val="solid"/>
                       <a:round/>
@@ -7479,7 +7479,7 @@
                     </a:lnR>
                     <a:lnT w="6350" cap="flat" cmpd="sng" algn="ctr">
                       <a:solidFill>
-                        <a:srgbClr val="A9CFC9"/>
+                        <a:srgbClr val="2F4A63"/>
                       </a:solidFill>
                       <a:prstDash val="solid"/>
                       <a:round/>
@@ -7488,7 +7488,7 @@
                     </a:lnT>
                     <a:lnB w="6350" cap="flat" cmpd="sng" algn="ctr">
                       <a:solidFill>
-                        <a:srgbClr val="A9CFC9"/>
+                        <a:srgbClr val="2F4A63"/>
                       </a:solidFill>
                       <a:prstDash val="solid"/>
                       <a:round/>
@@ -7522,7 +7522,7 @@
                   <a:tcPr marL="73152" marR="73152" marT="73152" marB="73152" anchor="ctr">
                     <a:lnL w="6350" cap="flat" cmpd="sng" algn="ctr">
                       <a:solidFill>
-                        <a:srgbClr val="A9CFC9"/>
+                        <a:srgbClr val="2F4A63"/>
                       </a:solidFill>
                       <a:prstDash val="solid"/>
                       <a:round/>
@@ -7531,7 +7531,7 @@
                     </a:lnL>
                     <a:lnR w="6350" cap="flat" cmpd="sng" algn="ctr">
                       <a:solidFill>
-                        <a:srgbClr val="A9CFC9"/>
+                        <a:srgbClr val="2F4A63"/>
                       </a:solidFill>
                       <a:prstDash val="solid"/>
                       <a:round/>
@@ -7540,7 +7540,7 @@
                     </a:lnR>
                     <a:lnT w="6350" cap="flat" cmpd="sng" algn="ctr">
                       <a:solidFill>
-                        <a:srgbClr val="A9CFC9"/>
+                        <a:srgbClr val="2F4A63"/>
                       </a:solidFill>
                       <a:prstDash val="solid"/>
                       <a:round/>
@@ -7549,7 +7549,7 @@
                     </a:lnT>
                     <a:lnB w="6350" cap="flat" cmpd="sng" algn="ctr">
                       <a:solidFill>
-                        <a:srgbClr val="A9CFC9"/>
+                        <a:srgbClr val="2F4A63"/>
                       </a:solidFill>
                       <a:prstDash val="solid"/>
                       <a:round/>
@@ -7585,7 +7585,7 @@
                   <a:tcPr marL="73152" marR="73152" marT="73152" marB="73152" anchor="ctr">
                     <a:lnL w="6350" cap="flat" cmpd="sng" algn="ctr">
                       <a:solidFill>
-                        <a:srgbClr val="A9CFC9"/>
+                        <a:srgbClr val="2F4A63"/>
                       </a:solidFill>
                       <a:prstDash val="solid"/>
                       <a:round/>
@@ -7594,7 +7594,7 @@
                     </a:lnL>
                     <a:lnR w="6350" cap="flat" cmpd="sng" algn="ctr">
                       <a:solidFill>
-                        <a:srgbClr val="A9CFC9"/>
+                        <a:srgbClr val="2F4A63"/>
                       </a:solidFill>
                       <a:prstDash val="solid"/>
                       <a:round/>
@@ -7603,7 +7603,7 @@
                     </a:lnR>
                     <a:lnT w="6350" cap="flat" cmpd="sng" algn="ctr">
                       <a:solidFill>
-                        <a:srgbClr val="A9CFC9"/>
+                        <a:srgbClr val="2F4A63"/>
                       </a:solidFill>
                       <a:prstDash val="solid"/>
                       <a:round/>
@@ -7612,7 +7612,7 @@
                     </a:lnT>
                     <a:lnB w="6350" cap="flat" cmpd="sng" algn="ctr">
                       <a:solidFill>
-                        <a:srgbClr val="A9CFC9"/>
+                        <a:srgbClr val="2F4A63"/>
                       </a:solidFill>
                       <a:prstDash val="solid"/>
                       <a:round/>
@@ -7646,7 +7646,7 @@
                   <a:tcPr marL="73152" marR="73152" marT="73152" marB="73152" anchor="ctr">
                     <a:lnL w="6350" cap="flat" cmpd="sng" algn="ctr">
                       <a:solidFill>
-                        <a:srgbClr val="A9CFC9"/>
+                        <a:srgbClr val="2F4A63"/>
                       </a:solidFill>
                       <a:prstDash val="solid"/>
                       <a:round/>
@@ -7655,7 +7655,7 @@
                     </a:lnL>
                     <a:lnR w="6350" cap="flat" cmpd="sng" algn="ctr">
                       <a:solidFill>
-                        <a:srgbClr val="A9CFC9"/>
+                        <a:srgbClr val="2F4A63"/>
                       </a:solidFill>
                       <a:prstDash val="solid"/>
                       <a:round/>
@@ -7664,7 +7664,7 @@
                     </a:lnR>
                     <a:lnT w="6350" cap="flat" cmpd="sng" algn="ctr">
                       <a:solidFill>
-                        <a:srgbClr val="A9CFC9"/>
+                        <a:srgbClr val="2F4A63"/>
                       </a:solidFill>
                       <a:prstDash val="solid"/>
                       <a:round/>
@@ -7673,7 +7673,7 @@
                     </a:lnT>
                     <a:lnB w="6350" cap="flat" cmpd="sng" algn="ctr">
                       <a:solidFill>
-                        <a:srgbClr val="A9CFC9"/>
+                        <a:srgbClr val="2F4A63"/>
                       </a:solidFill>
                       <a:prstDash val="solid"/>
                       <a:round/>
@@ -7707,7 +7707,7 @@
                   <a:tcPr marL="73152" marR="73152" marT="73152" marB="73152" anchor="ctr">
                     <a:lnL w="6350" cap="flat" cmpd="sng" algn="ctr">
                       <a:solidFill>
-                        <a:srgbClr val="A9CFC9"/>
+                        <a:srgbClr val="2F4A63"/>
                       </a:solidFill>
                       <a:prstDash val="solid"/>
                       <a:round/>
@@ -7716,7 +7716,7 @@
                     </a:lnL>
                     <a:lnR w="6350" cap="flat" cmpd="sng" algn="ctr">
                       <a:solidFill>
-                        <a:srgbClr val="A9CFC9"/>
+                        <a:srgbClr val="2F4A63"/>
                       </a:solidFill>
                       <a:prstDash val="solid"/>
                       <a:round/>
@@ -7725,7 +7725,7 @@
                     </a:lnR>
                     <a:lnT w="6350" cap="flat" cmpd="sng" algn="ctr">
                       <a:solidFill>
-                        <a:srgbClr val="A9CFC9"/>
+                        <a:srgbClr val="2F4A63"/>
                       </a:solidFill>
                       <a:prstDash val="solid"/>
                       <a:round/>
@@ -7734,7 +7734,7 @@
                     </a:lnT>
                     <a:lnB w="6350" cap="flat" cmpd="sng" algn="ctr">
                       <a:solidFill>
-                        <a:srgbClr val="A9CFC9"/>
+                        <a:srgbClr val="2F4A63"/>
                       </a:solidFill>
                       <a:prstDash val="solid"/>
                       <a:round/>
@@ -7770,7 +7770,7 @@
                   <a:tcPr marL="73152" marR="73152" marT="73152" marB="73152" anchor="ctr">
                     <a:lnL w="6350" cap="flat" cmpd="sng" algn="ctr">
                       <a:solidFill>
-                        <a:srgbClr val="A9CFC9"/>
+                        <a:srgbClr val="2F4A63"/>
                       </a:solidFill>
                       <a:prstDash val="solid"/>
                       <a:round/>
@@ -7779,7 +7779,7 @@
                     </a:lnL>
                     <a:lnR w="6350" cap="flat" cmpd="sng" algn="ctr">
                       <a:solidFill>
-                        <a:srgbClr val="A9CFC9"/>
+                        <a:srgbClr val="2F4A63"/>
                       </a:solidFill>
                       <a:prstDash val="solid"/>
                       <a:round/>
@@ -7788,7 +7788,7 @@
                     </a:lnR>
                     <a:lnT w="6350" cap="flat" cmpd="sng" algn="ctr">
                       <a:solidFill>
-                        <a:srgbClr val="A9CFC9"/>
+                        <a:srgbClr val="2F4A63"/>
                       </a:solidFill>
                       <a:prstDash val="solid"/>
                       <a:round/>
@@ -7797,7 +7797,7 @@
                     </a:lnT>
                     <a:lnB w="6350" cap="flat" cmpd="sng" algn="ctr">
                       <a:solidFill>
-                        <a:srgbClr val="A9CFC9"/>
+                        <a:srgbClr val="2F4A63"/>
                       </a:solidFill>
                       <a:prstDash val="solid"/>
                       <a:round/>
@@ -7831,7 +7831,7 @@
                   <a:tcPr marL="73152" marR="73152" marT="73152" marB="73152" anchor="ctr">
                     <a:lnL w="6350" cap="flat" cmpd="sng" algn="ctr">
                       <a:solidFill>
-                        <a:srgbClr val="A9CFC9"/>
+                        <a:srgbClr val="2F4A63"/>
                       </a:solidFill>
                       <a:prstDash val="solid"/>
                       <a:round/>
@@ -7840,7 +7840,7 @@
                     </a:lnL>
                     <a:lnR w="6350" cap="flat" cmpd="sng" algn="ctr">
                       <a:solidFill>
-                        <a:srgbClr val="A9CFC9"/>
+                        <a:srgbClr val="2F4A63"/>
                       </a:solidFill>
                       <a:prstDash val="solid"/>
                       <a:round/>
@@ -7849,7 +7849,7 @@
                     </a:lnR>
                     <a:lnT w="6350" cap="flat" cmpd="sng" algn="ctr">
                       <a:solidFill>
-                        <a:srgbClr val="A9CFC9"/>
+                        <a:srgbClr val="2F4A63"/>
                       </a:solidFill>
                       <a:prstDash val="solid"/>
                       <a:round/>
@@ -7858,7 +7858,7 @@
                     </a:lnT>
                     <a:lnB w="6350" cap="flat" cmpd="sng" algn="ctr">
                       <a:solidFill>
-                        <a:srgbClr val="A9CFC9"/>
+                        <a:srgbClr val="2F4A63"/>
                       </a:solidFill>
                       <a:prstDash val="solid"/>
                       <a:round/>
@@ -7892,7 +7892,7 @@
                   <a:tcPr marL="73152" marR="73152" marT="73152" marB="73152" anchor="ctr">
                     <a:lnL w="6350" cap="flat" cmpd="sng" algn="ctr">
                       <a:solidFill>
-                        <a:srgbClr val="A9CFC9"/>
+                        <a:srgbClr val="2F4A63"/>
                       </a:solidFill>
                       <a:prstDash val="solid"/>
                       <a:round/>
@@ -7901,7 +7901,7 @@
                     </a:lnL>
                     <a:lnR w="6350" cap="flat" cmpd="sng" algn="ctr">
                       <a:solidFill>
-                        <a:srgbClr val="A9CFC9"/>
+                        <a:srgbClr val="2F4A63"/>
                       </a:solidFill>
                       <a:prstDash val="solid"/>
                       <a:round/>
@@ -7910,7 +7910,7 @@
                     </a:lnR>
                     <a:lnT w="6350" cap="flat" cmpd="sng" algn="ctr">
                       <a:solidFill>
-                        <a:srgbClr val="A9CFC9"/>
+                        <a:srgbClr val="2F4A63"/>
                       </a:solidFill>
                       <a:prstDash val="solid"/>
                       <a:round/>
@@ -7919,7 +7919,7 @@
                     </a:lnT>
                     <a:lnB w="6350" cap="flat" cmpd="sng" algn="ctr">
                       <a:solidFill>
-                        <a:srgbClr val="A9CFC9"/>
+                        <a:srgbClr val="2F4A63"/>
                       </a:solidFill>
                       <a:prstDash val="solid"/>
                       <a:round/>
@@ -8100,7 +8100,7 @@
           <a:noFill/>
           <a:ln w="25400">
             <a:solidFill>
-              <a:srgbClr val="A9CFC9"/>
+              <a:srgbClr val="2F4A63"/>
             </a:solidFill>
             <a:prstDash val="solid"/>
           </a:ln>
@@ -8455,8 +8455,8 @@
           <a:ln/>
           <a:effectLst>
             <a:outerShdw sx="100000" sy="100000" kx="0" ky="0" algn="bl" rotWithShape="0" blurRad="76200" dist="25400" dir="5400000">
-              <a:srgbClr val="1A3640">
-                <a:alpha val="14000"/>
+              <a:srgbClr val="000000">
+                <a:alpha val="35000"/>
               </a:srgbClr>
             </a:outerShdw>
           </a:effectLst>
@@ -8612,8 +8612,8 @@
           <a:ln/>
           <a:effectLst>
             <a:outerShdw sx="100000" sy="100000" kx="0" ky="0" algn="bl" rotWithShape="0" blurRad="76200" dist="25400" dir="5400000">
-              <a:srgbClr val="1A3640">
-                <a:alpha val="14000"/>
+              <a:srgbClr val="000000">
+                <a:alpha val="35000"/>
               </a:srgbClr>
             </a:outerShdw>
           </a:effectLst>
@@ -8769,8 +8769,8 @@
           <a:ln/>
           <a:effectLst>
             <a:outerShdw sx="100000" sy="100000" kx="0" ky="0" algn="bl" rotWithShape="0" blurRad="76200" dist="25400" dir="5400000">
-              <a:srgbClr val="1A3640">
-                <a:alpha val="14000"/>
+              <a:srgbClr val="000000">
+                <a:alpha val="35000"/>
               </a:srgbClr>
             </a:outerShdw>
           </a:effectLst>
@@ -9003,7 +9003,7 @@
             <a:r>
               <a:rPr lang="en-US" sz="3600" b="1" dirty="0">
                 <a:solidFill>
-                  <a:schemeClr val="bg1"/>
+                  <a:schemeClr val="tx1"/>
                 </a:solidFill>
                 <a:latin typeface="Cambria" pitchFamily="34" charset="0"/>
                 <a:ea typeface="Cambria" pitchFamily="34" charset="-122"/>
@@ -9044,7 +9044,7 @@
             <a:r>
               <a:rPr lang="en-US" sz="1500" b="1" dirty="0">
                 <a:solidFill>
-                  <a:schemeClr val="bg1"/>
+                  <a:schemeClr val="accent2"/>
                 </a:solidFill>
               </a:rPr>
               <a:t>Right tool. Sharp prompt. Proven result.</a:t>
@@ -9058,7 +9058,7 @@
             <a:r>
               <a:rPr lang="en-US" sz="1500" dirty="0">
                 <a:solidFill>
-                  <a:schemeClr val="accent6"/>
+                  <a:schemeClr val="accent5"/>
                 </a:solidFill>
               </a:rPr>
               <a:t>Double-click Start-Coach.bat, or run python -m compass</a:t>
@@ -9072,7 +9072,7 @@
             <a:r>
               <a:rPr lang="en-US" sz="1200" dirty="0">
                 <a:solidFill>
-                  <a:schemeClr val="accent6"/>
+                  <a:schemeClr val="accent5"/>
                 </a:solidFill>
               </a:rPr>
               <a:t>github.com/Kalyanraja/compass-ai-coach  |  MIT licensed</a:t>
@@ -9098,7 +9098,7 @@
         <p:spPr>
           <a:xfrm>
             <a:off x="548640" y="3520440"/>
-            <a:ext cx="4206240" cy="1261872"/>
+            <a:ext cx="4206240" cy="1121664"/>
           </a:xfrm>
           <a:prstGeom prst="rect">
             <a:avLst/>
@@ -9121,8 +9121,8 @@
         </p:blipFill>
         <p:spPr>
           <a:xfrm>
-            <a:off x="5440680" y="868680"/>
-            <a:ext cx="3383280" cy="3383280"/>
+            <a:off x="5303520" y="685800"/>
+            <a:ext cx="3703320" cy="3703320"/>
           </a:xfrm>
           <a:prstGeom prst="rect">
             <a:avLst/>
@@ -9217,8 +9217,8 @@
           <a:ln/>
           <a:effectLst>
             <a:outerShdw sx="100000" sy="100000" kx="0" ky="0" algn="bl" rotWithShape="0" blurRad="76200" dist="25400" dir="5400000">
-              <a:srgbClr val="1A3640">
-                <a:alpha val="14000"/>
+              <a:srgbClr val="000000">
+                <a:alpha val="35000"/>
               </a:srgbClr>
             </a:outerShdw>
           </a:effectLst>
@@ -9357,8 +9357,8 @@
           <a:ln/>
           <a:effectLst>
             <a:outerShdw sx="100000" sy="100000" kx="0" ky="0" algn="bl" rotWithShape="0" blurRad="76200" dist="25400" dir="5400000">
-              <a:srgbClr val="1A3640">
-                <a:alpha val="14000"/>
+              <a:srgbClr val="000000">
+                <a:alpha val="35000"/>
               </a:srgbClr>
             </a:outerShdw>
           </a:effectLst>
@@ -9497,8 +9497,8 @@
           <a:ln/>
           <a:effectLst>
             <a:outerShdw sx="100000" sy="100000" kx="0" ky="0" algn="bl" rotWithShape="0" blurRad="76200" dist="25400" dir="5400000">
-              <a:srgbClr val="1A3640">
-                <a:alpha val="14000"/>
+              <a:srgbClr val="000000">
+                <a:alpha val="35000"/>
               </a:srgbClr>
             </a:outerShdw>
           </a:effectLst>
@@ -9659,7 +9659,7 @@
       </p:sp>
       <p:pic>
         <p:nvPicPr>
-          <p:cNvPr id="17" name="Image 0" descr="/tmp/claude-0/-home-claude-compass-ai-coach/3958fdaf-6357-5283-9722-e914f4fad239/scratchpad/deck/img/chart-w.png">    </p:cNvPr>
+          <p:cNvPr id="17" name="Image 0" descr="/tmp/claude-0/-home-claude-compass-ai-coach/3958fdaf-6357-5283-9722-e914f4fad239/scratchpad/deck/img/chart-d.png">    </p:cNvPr>
           <p:cNvPicPr>
             <a:picLocks noChangeAspect="1"/>
           </p:cNvPicPr>
@@ -9855,8 +9855,8 @@
         </p:blipFill>
         <p:spPr>
           <a:xfrm>
-            <a:off x="1463040" y="896112"/>
-            <a:ext cx="6217920" cy="2348992"/>
+            <a:off x="1737360" y="987552"/>
+            <a:ext cx="5669280" cy="2204720"/>
           </a:xfrm>
           <a:prstGeom prst="rect">
             <a:avLst/>
@@ -9885,8 +9885,8 @@
           <a:ln/>
           <a:effectLst>
             <a:outerShdw sx="100000" sy="100000" kx="0" ky="0" algn="bl" rotWithShape="0" blurRad="76200" dist="25400" dir="5400000">
-              <a:srgbClr val="1A3640">
-                <a:alpha val="14000"/>
+              <a:srgbClr val="000000">
+                <a:alpha val="35000"/>
               </a:srgbClr>
             </a:outerShdw>
           </a:effectLst>
@@ -9989,8 +9989,8 @@
           <a:ln/>
           <a:effectLst>
             <a:outerShdw sx="100000" sy="100000" kx="0" ky="0" algn="bl" rotWithShape="0" blurRad="76200" dist="25400" dir="5400000">
-              <a:srgbClr val="1A3640">
-                <a:alpha val="14000"/>
+              <a:srgbClr val="000000">
+                <a:alpha val="35000"/>
               </a:srgbClr>
             </a:outerShdw>
           </a:effectLst>
@@ -10093,8 +10093,8 @@
           <a:ln/>
           <a:effectLst>
             <a:outerShdw sx="100000" sy="100000" kx="0" ky="0" algn="bl" rotWithShape="0" blurRad="76200" dist="25400" dir="5400000">
-              <a:srgbClr val="1A3640">
-                <a:alpha val="14000"/>
+              <a:srgbClr val="000000">
+                <a:alpha val="35000"/>
               </a:srgbClr>
             </a:outerShdw>
           </a:effectLst>
@@ -10308,36 +10308,16 @@
           <a:ln/>
           <a:effectLst>
             <a:outerShdw sx="100000" sy="100000" kx="0" ky="0" algn="bl" rotWithShape="0" blurRad="76200" dist="25400" dir="5400000">
-              <a:srgbClr val="1A3640">
-                <a:alpha val="14000"/>
+              <a:srgbClr val="000000">
+                <a:alpha val="35000"/>
               </a:srgbClr>
             </a:outerShdw>
           </a:effectLst>
         </p:spPr>
       </p:sp>
-      <p:sp>
-        <p:nvSpPr>
-          <p:cNvPr id="4" name="Shape 2"/>
-          <p:cNvSpPr/>
-          <p:nvPr/>
-        </p:nvSpPr>
-        <p:spPr>
-          <a:xfrm>
-            <a:off x="685800" y="1280160"/>
-            <a:ext cx="548640" cy="548640"/>
-          </a:xfrm>
-          <a:prstGeom prst="ellipse">
-            <a:avLst/>
-          </a:prstGeom>
-          <a:solidFill>
-            <a:schemeClr val="accent1"/>
-          </a:solidFill>
-          <a:ln/>
-        </p:spPr>
-      </p:sp>
       <p:pic>
         <p:nvPicPr>
-          <p:cNvPr id="5" name="Image 0" descr="/tmp/claude-0/-home-claude-compass-ai-coach/3958fdaf-6357-5283-9722-e914f4fad239/scratchpad/deck/img/user-w.png">    </p:cNvPr>
+          <p:cNvPr id="4" name="Image 0" descr="/tmp/claude-0/-home-claude-compass-ai-coach/3958fdaf-6357-5283-9722-e914f4fad239/scratchpad/deck/img/person-engineer.png">    </p:cNvPr>
           <p:cNvPicPr>
             <a:picLocks noChangeAspect="1"/>
           </p:cNvPicPr>
@@ -10351,8 +10331,8 @@
         </p:blipFill>
         <p:spPr>
           <a:xfrm>
-            <a:off x="828446" y="1422806"/>
-            <a:ext cx="263347" cy="263347"/>
+            <a:off x="658368" y="1216152"/>
+            <a:ext cx="658368" cy="658368"/>
           </a:xfrm>
           <a:prstGeom prst="rect">
             <a:avLst/>
@@ -10361,7 +10341,7 @@
       </p:pic>
       <p:sp>
         <p:nvSpPr>
-          <p:cNvPr id="6" name="Text 3"/>
+          <p:cNvPr id="5" name="Text 2"/>
           <p:cNvSpPr txBox="1"/>
           <p:nvPr/>
         </p:nvSpPr>
@@ -10400,7 +10380,7 @@
       </p:sp>
       <p:sp>
         <p:nvSpPr>
-          <p:cNvPr id="7" name="Text 4"/>
+          <p:cNvPr id="6" name="Text 3"/>
           <p:cNvSpPr txBox="1"/>
           <p:nvPr/>
         </p:nvSpPr>
@@ -10476,7 +10456,7 @@
       </p:sp>
       <p:sp>
         <p:nvSpPr>
-          <p:cNvPr id="8" name="pillar-1"/>
+          <p:cNvPr id="7" name="pillar-1"/>
           <p:cNvSpPr/>
           <p:nvPr/>
         </p:nvSpPr>
@@ -10496,36 +10476,16 @@
           <a:ln/>
           <a:effectLst>
             <a:outerShdw sx="100000" sy="100000" kx="0" ky="0" algn="bl" rotWithShape="0" blurRad="76200" dist="25400" dir="5400000">
-              <a:srgbClr val="1A3640">
-                <a:alpha val="14000"/>
+              <a:srgbClr val="000000">
+                <a:alpha val="35000"/>
               </a:srgbClr>
             </a:outerShdw>
           </a:effectLst>
         </p:spPr>
       </p:sp>
-      <p:sp>
-        <p:nvSpPr>
-          <p:cNvPr id="9" name="Shape 6"/>
-          <p:cNvSpPr/>
-          <p:nvPr/>
-        </p:nvSpPr>
-        <p:spPr>
-          <a:xfrm>
-            <a:off x="3520440" y="1280160"/>
-            <a:ext cx="548640" cy="548640"/>
-          </a:xfrm>
-          <a:prstGeom prst="ellipse">
-            <a:avLst/>
-          </a:prstGeom>
-          <a:solidFill>
-            <a:schemeClr val="accent1"/>
-          </a:solidFill>
-          <a:ln/>
-        </p:spPr>
-      </p:sp>
       <p:pic>
         <p:nvPicPr>
-          <p:cNvPr id="10" name="Image 1" descr="/tmp/claude-0/-home-claude-compass-ai-coach/3958fdaf-6357-5283-9722-e914f4fad239/scratchpad/deck/img/users-w.png">    </p:cNvPr>
+          <p:cNvPr id="8" name="Image 1" descr="/tmp/claude-0/-home-claude-compass-ai-coach/3958fdaf-6357-5283-9722-e914f4fad239/scratchpad/deck/img/person-group.png">    </p:cNvPr>
           <p:cNvPicPr>
             <a:picLocks noChangeAspect="1"/>
           </p:cNvPicPr>
@@ -10539,8 +10499,8 @@
         </p:blipFill>
         <p:spPr>
           <a:xfrm>
-            <a:off x="3663086" y="1422806"/>
-            <a:ext cx="263347" cy="263347"/>
+            <a:off x="3493008" y="1216152"/>
+            <a:ext cx="658368" cy="658368"/>
           </a:xfrm>
           <a:prstGeom prst="rect">
             <a:avLst/>
@@ -10549,7 +10509,7 @@
       </p:pic>
       <p:sp>
         <p:nvSpPr>
-          <p:cNvPr id="11" name="Text 7"/>
+          <p:cNvPr id="9" name="Text 5"/>
           <p:cNvSpPr txBox="1"/>
           <p:nvPr/>
         </p:nvSpPr>
@@ -10588,7 +10548,7 @@
       </p:sp>
       <p:sp>
         <p:nvSpPr>
-          <p:cNvPr id="12" name="Text 8"/>
+          <p:cNvPr id="10" name="Text 6"/>
           <p:cNvSpPr txBox="1"/>
           <p:nvPr/>
         </p:nvSpPr>
@@ -10664,7 +10624,7 @@
       </p:sp>
       <p:sp>
         <p:nvSpPr>
-          <p:cNvPr id="13" name="pillar-2"/>
+          <p:cNvPr id="11" name="pillar-2"/>
           <p:cNvSpPr/>
           <p:nvPr/>
         </p:nvSpPr>
@@ -10684,36 +10644,16 @@
           <a:ln/>
           <a:effectLst>
             <a:outerShdw sx="100000" sy="100000" kx="0" ky="0" algn="bl" rotWithShape="0" blurRad="76200" dist="25400" dir="5400000">
-              <a:srgbClr val="1A3640">
-                <a:alpha val="14000"/>
+              <a:srgbClr val="000000">
+                <a:alpha val="35000"/>
               </a:srgbClr>
             </a:outerShdw>
           </a:effectLst>
         </p:spPr>
       </p:sp>
-      <p:sp>
-        <p:nvSpPr>
-          <p:cNvPr id="14" name="Shape 10"/>
-          <p:cNvSpPr/>
-          <p:nvPr/>
-        </p:nvSpPr>
-        <p:spPr>
-          <a:xfrm>
-            <a:off x="6355080" y="1280160"/>
-            <a:ext cx="548640" cy="548640"/>
-          </a:xfrm>
-          <a:prstGeom prst="ellipse">
-            <a:avLst/>
-          </a:prstGeom>
-          <a:solidFill>
-            <a:schemeClr val="accent1"/>
-          </a:solidFill>
-          <a:ln/>
-        </p:spPr>
-      </p:sp>
       <p:pic>
         <p:nvPicPr>
-          <p:cNvPr id="15" name="Image 2" descr="/tmp/claude-0/-home-claude-compass-ai-coach/3958fdaf-6357-5283-9722-e914f4fad239/scratchpad/deck/img/route-w.png">    </p:cNvPr>
+          <p:cNvPr id="12" name="Image 2" descr="/tmp/claude-0/-home-claude-compass-ai-coach/3958fdaf-6357-5283-9722-e914f4fad239/scratchpad/deck/img/person-coach.png">    </p:cNvPr>
           <p:cNvPicPr>
             <a:picLocks noChangeAspect="1"/>
           </p:cNvPicPr>
@@ -10727,8 +10667,8 @@
         </p:blipFill>
         <p:spPr>
           <a:xfrm>
-            <a:off x="6497726" y="1422806"/>
-            <a:ext cx="263347" cy="263347"/>
+            <a:off x="6327648" y="1216152"/>
+            <a:ext cx="658368" cy="658368"/>
           </a:xfrm>
           <a:prstGeom prst="rect">
             <a:avLst/>
@@ -10737,7 +10677,7 @@
       </p:pic>
       <p:sp>
         <p:nvSpPr>
-          <p:cNvPr id="16" name="Text 11"/>
+          <p:cNvPr id="13" name="Text 8"/>
           <p:cNvSpPr txBox="1"/>
           <p:nvPr/>
         </p:nvSpPr>
@@ -10776,7 +10716,7 @@
       </p:sp>
       <p:sp>
         <p:nvSpPr>
-          <p:cNvPr id="17" name="Text 12"/>
+          <p:cNvPr id="14" name="Text 9"/>
           <p:cNvSpPr txBox="1"/>
           <p:nvPr/>
         </p:nvSpPr>
@@ -10852,7 +10792,7 @@
       </p:sp>
       <p:sp>
         <p:nvSpPr>
-          <p:cNvPr id="18" name="Text 13"/>
+          <p:cNvPr id="15" name="Text 10"/>
           <p:cNvSpPr txBox="1"/>
           <p:nvPr/>
         </p:nvSpPr>
@@ -11018,7 +10958,7 @@
           </a:solidFill>
           <a:ln w="12700">
             <a:solidFill>
-              <a:srgbClr val="A9CFC9"/>
+              <a:srgbClr val="2F4A63"/>
             </a:solidFill>
             <a:prstDash val="dash"/>
           </a:ln>
@@ -12119,7 +12059,7 @@
           <a:noFill/>
           <a:ln w="19050">
             <a:solidFill>
-              <a:srgbClr val="1D5C63"/>
+              <a:srgbClr val="7FD8CF"/>
             </a:solidFill>
             <a:prstDash val="solid"/>
             <a:tailEnd type="triangle"/>
@@ -12143,7 +12083,7 @@
           <a:noFill/>
           <a:ln w="19050">
             <a:solidFill>
-              <a:srgbClr val="1D5C63"/>
+              <a:srgbClr val="7FD8CF"/>
             </a:solidFill>
             <a:prstDash val="solid"/>
             <a:tailEnd type="triangle"/>
@@ -12167,7 +12107,7 @@
           <a:noFill/>
           <a:ln w="19050">
             <a:solidFill>
-              <a:srgbClr val="1D5C63"/>
+              <a:srgbClr val="7FD8CF"/>
             </a:solidFill>
             <a:prstDash val="solid"/>
             <a:tailEnd type="triangle"/>
@@ -12191,7 +12131,7 @@
           <a:noFill/>
           <a:ln w="19050">
             <a:solidFill>
-              <a:srgbClr val="1D5C63"/>
+              <a:srgbClr val="7FD8CF"/>
             </a:solidFill>
             <a:prstDash val="solid"/>
             <a:tailEnd type="triangle"/>
@@ -12215,7 +12155,7 @@
           <a:noFill/>
           <a:ln w="19050">
             <a:solidFill>
-              <a:srgbClr val="1D5C63"/>
+              <a:srgbClr val="7FD8CF"/>
             </a:solidFill>
             <a:prstDash val="solid"/>
             <a:tailEnd type="triangle"/>
@@ -12239,7 +12179,7 @@
           <a:noFill/>
           <a:ln w="19050">
             <a:solidFill>
-              <a:srgbClr val="1D5C63"/>
+              <a:srgbClr val="7FD8CF"/>
             </a:solidFill>
             <a:prstDash val="solid"/>
             <a:tailEnd type="triangle"/>
@@ -12263,7 +12203,7 @@
           <a:noFill/>
           <a:ln w="19050">
             <a:solidFill>
-              <a:srgbClr val="1D5C63"/>
+              <a:srgbClr val="7FD8CF"/>
             </a:solidFill>
             <a:prstDash val="solid"/>
             <a:tailEnd type="triangle"/>
@@ -12287,7 +12227,7 @@
           <a:noFill/>
           <a:ln w="19050">
             <a:solidFill>
-              <a:srgbClr val="1D5C63"/>
+              <a:srgbClr val="7FD8CF"/>
             </a:solidFill>
             <a:prstDash val="solid"/>
             <a:tailEnd type="triangle"/>
@@ -12433,7 +12373,7 @@
           <a:noFill/>
           <a:ln w="19050">
             <a:solidFill>
-              <a:srgbClr val="1D5C63"/>
+              <a:srgbClr val="7FD8CF"/>
             </a:solidFill>
             <a:prstDash val="solid"/>
             <a:tailEnd type="triangle"/>
@@ -12615,7 +12555,7 @@
           <a:noFill/>
           <a:ln w="19050">
             <a:solidFill>
-              <a:srgbClr val="1D5C63"/>
+              <a:srgbClr val="7FD8CF"/>
             </a:solidFill>
             <a:prstDash val="solid"/>
             <a:tailEnd type="triangle"/>
@@ -12639,7 +12579,7 @@
           <a:noFill/>
           <a:ln w="19050">
             <a:solidFill>
-              <a:srgbClr val="C77D1E"/>
+              <a:srgbClr val="F2B544"/>
             </a:solidFill>
             <a:prstDash val="dash"/>
             <a:tailEnd type="triangle"/>
@@ -12774,7 +12714,7 @@
           <a:noFill/>
           <a:ln w="25400">
             <a:solidFill>
-              <a:srgbClr val="A9CFC9"/>
+              <a:srgbClr val="2F4A63"/>
             </a:solidFill>
             <a:prstDash val="solid"/>
           </a:ln>
@@ -13733,8 +13673,8 @@
           <a:ln/>
           <a:effectLst>
             <a:outerShdw sx="100000" sy="100000" kx="0" ky="0" algn="bl" rotWithShape="0" blurRad="76200" dist="25400" dir="5400000">
-              <a:srgbClr val="1A3640">
-                <a:alpha val="14000"/>
+              <a:srgbClr val="000000">
+                <a:alpha val="35000"/>
               </a:srgbClr>
             </a:outerShdw>
           </a:effectLst>
@@ -13762,7 +13702,7 @@
       </p:sp>
       <p:pic>
         <p:nvPicPr>
-          <p:cNvPr id="34" name="Image 0" descr="/tmp/claude-0/-home-claude-compass-ai-coach/3958fdaf-6357-5283-9722-e914f4fad239/scratchpad/deck/img/route-w.png">    </p:cNvPr>
+          <p:cNvPr id="34" name="Image 0" descr="/tmp/claude-0/-home-claude-compass-ai-coach/3958fdaf-6357-5283-9722-e914f4fad239/scratchpad/deck/img/route-d.png">    </p:cNvPr>
           <p:cNvPicPr>
             <a:picLocks noChangeAspect="1"/>
           </p:cNvPicPr>
@@ -13878,8 +13818,8 @@
           <a:ln/>
           <a:effectLst>
             <a:outerShdw sx="100000" sy="100000" kx="0" ky="0" algn="bl" rotWithShape="0" blurRad="76200" dist="25400" dir="5400000">
-              <a:srgbClr val="1A3640">
-                <a:alpha val="14000"/>
+              <a:srgbClr val="000000">
+                <a:alpha val="35000"/>
               </a:srgbClr>
             </a:outerShdw>
           </a:effectLst>
@@ -13907,7 +13847,7 @@
       </p:sp>
       <p:pic>
         <p:nvPicPr>
-          <p:cNvPr id="39" name="Image 1" descr="/tmp/claude-0/-home-claude-compass-ai-coach/3958fdaf-6357-5283-9722-e914f4fad239/scratchpad/deck/img/bug-w.png">    </p:cNvPr>
+          <p:cNvPr id="39" name="Image 1" descr="/tmp/claude-0/-home-claude-compass-ai-coach/3958fdaf-6357-5283-9722-e914f4fad239/scratchpad/deck/img/bug-d.png">    </p:cNvPr>
           <p:cNvPicPr>
             <a:picLocks noChangeAspect="1"/>
           </p:cNvPicPr>
@@ -14023,8 +13963,8 @@
           <a:ln/>
           <a:effectLst>
             <a:outerShdw sx="100000" sy="100000" kx="0" ky="0" algn="bl" rotWithShape="0" blurRad="76200" dist="25400" dir="5400000">
-              <a:srgbClr val="1A3640">
-                <a:alpha val="14000"/>
+              <a:srgbClr val="000000">
+                <a:alpha val="35000"/>
               </a:srgbClr>
             </a:outerShdw>
           </a:effectLst>
@@ -14052,7 +13992,7 @@
       </p:sp>
       <p:pic>
         <p:nvPicPr>
-          <p:cNvPr id="44" name="Image 2" descr="/tmp/claude-0/-home-claude-compass-ai-coach/3958fdaf-6357-5283-9722-e914f4fad239/scratchpad/deck/img/vial-w.png">    </p:cNvPr>
+          <p:cNvPr id="44" name="Image 2" descr="/tmp/claude-0/-home-claude-compass-ai-coach/3958fdaf-6357-5283-9722-e914f4fad239/scratchpad/deck/img/vial-d.png">    </p:cNvPr>
           <p:cNvPicPr>
             <a:picLocks noChangeAspect="1"/>
           </p:cNvPicPr>
@@ -14167,14 +14107,14 @@
           </a:solidFill>
           <a:ln w="12700">
             <a:solidFill>
-              <a:srgbClr val="A9CFC9"/>
+              <a:srgbClr val="2F4A63"/>
             </a:solidFill>
             <a:prstDash val="solid"/>
           </a:ln>
           <a:effectLst>
             <a:outerShdw sx="100000" sy="100000" kx="0" ky="0" algn="bl" rotWithShape="0" blurRad="76200" dist="25400" dir="5400000">
-              <a:srgbClr val="1A3640">
-                <a:alpha val="14000"/>
+              <a:srgbClr val="000000">
+                <a:alpha val="35000"/>
               </a:srgbClr>
             </a:outerShdw>
           </a:effectLst>
@@ -14202,7 +14142,7 @@
       </p:sp>
       <p:pic>
         <p:nvPicPr>
-          <p:cNvPr id="49" name="Image 3" descr="/tmp/claude-0/-home-claude-compass-ai-coach/3958fdaf-6357-5283-9722-e914f4fad239/scratchpad/deck/img/shield-w.png">    </p:cNvPr>
+          <p:cNvPr id="49" name="Image 3" descr="/tmp/claude-0/-home-claude-compass-ai-coach/3958fdaf-6357-5283-9722-e914f4fad239/scratchpad/deck/img/shield-d.png">    </p:cNvPr>
           <p:cNvPicPr>
             <a:picLocks noChangeAspect="1"/>
           </p:cNvPicPr>
@@ -14650,14 +14590,14 @@
           </a:solidFill>
           <a:ln w="12700">
             <a:solidFill>
-              <a:srgbClr val="A9CFC9"/>
+              <a:srgbClr val="2F4A63"/>
             </a:solidFill>
             <a:prstDash val="solid"/>
           </a:ln>
           <a:effectLst>
             <a:outerShdw sx="100000" sy="100000" kx="0" ky="0" algn="bl" rotWithShape="0" blurRad="76200" dist="25400" dir="5400000">
-              <a:srgbClr val="1A3640">
-                <a:alpha val="14000"/>
+              <a:srgbClr val="000000">
+                <a:alpha val="35000"/>
               </a:srgbClr>
             </a:outerShdw>
           </a:effectLst>
@@ -14933,14 +14873,14 @@
           </a:solidFill>
           <a:ln w="12700">
             <a:solidFill>
-              <a:srgbClr val="A9CFC9"/>
+              <a:srgbClr val="2F4A63"/>
             </a:solidFill>
             <a:prstDash val="solid"/>
           </a:ln>
           <a:effectLst>
             <a:outerShdw sx="100000" sy="100000" kx="0" ky="0" algn="bl" rotWithShape="0" blurRad="76200" dist="25400" dir="5400000">
-              <a:srgbClr val="1A3640">
-                <a:alpha val="14000"/>
+              <a:srgbClr val="000000">
+                <a:alpha val="35000"/>
               </a:srgbClr>
             </a:outerShdw>
           </a:effectLst>
@@ -14989,14 +14929,14 @@
           </a:solidFill>
           <a:ln w="12700">
             <a:solidFill>
-              <a:srgbClr val="A9CFC9"/>
+              <a:srgbClr val="2F4A63"/>
             </a:solidFill>
             <a:prstDash val="solid"/>
           </a:ln>
           <a:effectLst>
             <a:outerShdw sx="100000" sy="100000" kx="0" ky="0" algn="bl" rotWithShape="0" blurRad="76200" dist="25400" dir="5400000">
-              <a:srgbClr val="1A3640">
-                <a:alpha val="14000"/>
+              <a:srgbClr val="000000">
+                <a:alpha val="35000"/>
               </a:srgbClr>
             </a:outerShdw>
           </a:effectLst>
@@ -15380,14 +15320,14 @@
           </a:solidFill>
           <a:ln w="12700">
             <a:solidFill>
-              <a:srgbClr val="A9CFC9"/>
+              <a:srgbClr val="2F4A63"/>
             </a:solidFill>
             <a:prstDash val="solid"/>
           </a:ln>
           <a:effectLst>
             <a:outerShdw sx="100000" sy="100000" kx="0" ky="0" algn="bl" rotWithShape="0" blurRad="76200" dist="25400" dir="5400000">
-              <a:srgbClr val="1A3640">
-                <a:alpha val="14000"/>
+              <a:srgbClr val="000000">
+                <a:alpha val="35000"/>
               </a:srgbClr>
             </a:outerShdw>
           </a:effectLst>
@@ -15475,40 +15415,40 @@
   <a:themeElements>
     <a:clrScheme name="Compass">
       <a:dk1>
-        <a:srgbClr val="102A35"/>
+        <a:srgbClr val="F2F5F8"/>
       </a:dk1>
       <a:lt1>
-        <a:srgbClr val="FFFFFF"/>
+        <a:srgbClr val="0B1B2B"/>
       </a:lt1>
       <a:dk2>
-        <a:srgbClr val="1D5C63"/>
+        <a:srgbClr val="7FD8CF"/>
       </a:dk2>
       <a:lt2>
-        <a:srgbClr val="EEF4F3"/>
+        <a:srgbClr val="13283D"/>
       </a:lt2>
       <a:accent1>
-        <a:srgbClr val="1D6E6B"/>
+        <a:srgbClr val="2EC4B6"/>
       </a:accent1>
       <a:accent2>
-        <a:srgbClr val="C77D1E"/>
+        <a:srgbClr val="F2B544"/>
       </a:accent2>
       <a:accent3>
-        <a:srgbClr val="B8432F"/>
+        <a:srgbClr val="F0715A"/>
       </a:accent3>
       <a:accent4>
-        <a:srgbClr val="2E7D4F"/>
+        <a:srgbClr val="5DD39E"/>
       </a:accent4>
       <a:accent5>
-        <a:srgbClr val="5E7279"/>
+        <a:srgbClr val="8FA3B3"/>
       </a:accent5>
       <a:accent6>
-        <a:srgbClr val="A9CFC9"/>
+        <a:srgbClr val="2F4A63"/>
       </a:accent6>
       <a:hlink>
-        <a:srgbClr val="1D6E6B"/>
+        <a:srgbClr val="2EC4B6"/>
       </a:hlink>
       <a:folHlink>
-        <a:srgbClr val="5E7279"/>
+        <a:srgbClr val="8FA3B3"/>
       </a:folHlink>
     </a:clrScheme>
     <a:fontScheme name="Compass">

</xml_diff>